<commit_message>
refactor(ingenieria-desarrollo-movil): proyecto de aula (FO-IV-159) en lugar de ABP
Guía, plantillas con el formato FO-IV-159, presentación y unidades corregidas; menos recuadros
con emoji; las rutas abp/ redirigen a proyecto-aula/.

Co-Authored-By: Claude Opus 5.5 <noreply@anthropic.com>
</commit_message>
<xml_diff>
--- a/2026-B/ingenieria-desarrollo-movil/unidad-01/slides/unidad01arquitectura-hibrida.pptx
+++ b/2026-B/ingenieria-desarrollo-movil/unidad-01/slides/unidad01arquitectura-hibrida.pptx
@@ -1331,7 +1331,7 @@
           <a:lstStyle/>
           <a:p>
             <a:r>
-              <a:t>EN VIVO. Leer en voz de capacidad, no de contenido. Aclarar qué es este documento: material de apoyo de la unidad completa, no el guion de la hora; en el encuentro se recorre una parte y el resto queda para estudiar. Ruta de la unidad: el material institucional recorre cuatro bloques (1. desarrollo híbrido, Ionic, Capacitor, frameworks y beneficios; 2. anatomía del proyecto, organización modular, rutas, lazy loading y Clean Code; 3. herramientas: Ionic CLI, Capacitor, Android Studio y Xcode; 4. ejecución y depuración en simuladores y dispositivos) y aquí se estudian los mismos cuatro con la lente arquitectónica, más un agregado del curso: gobierno y método SDD. Recorrido sugerido en vivo (el encuentro también lanza el ABP con su propio deck): imprescindibles 1 a 4, 7 a 10, 15, 17, 22, 25, 35, 44 y 45, con las preguntas en vivo 8, 14 y 31; si sobra tiempo, 11, 13, 18, 19, 26, 28, 34, 40 y 43. Todo lo demás es de consulta: las notas de cada slide lo marcan.</a:t>
+              <a:t>EN VIVO. Leer en voz de capacidad, no de contenido. Aclarar qué es este documento: material de apoyo de la unidad completa, no el guion de la hora; en el encuentro se recorre una parte y el resto queda para estudiar. Ruta de la unidad: el material institucional recorre cuatro bloques (1. desarrollo híbrido, Ionic, Capacitor, frameworks y beneficios; 2. anatomía del proyecto, organización modular, rutas, lazy loading y Clean Code; 3. herramientas: Ionic CLI, Capacitor, Android Studio y Xcode; 4. ejecución y depuración en simuladores y dispositivos) y aquí se estudian los mismos cuatro con la lente arquitectónica, más un agregado del curso: gobierno y método SDD. Recorrido sugerido en vivo (el encuentro también lanza el proyecto de aula con su propio deck): imprescindibles 1 a 4, 7 a 10, 15, 17, 22, 25, 35, 44 y 45, con las preguntas en vivo 8, 14 y 31; si sobra tiempo, 11, 13, 18, 19, 26, 28, 34, 40 y 43. Todo lo demás es de consulta: las notas de cada slide lo marcan.</a:t>
             </a:r>
           </a:p>
         </p:txBody>
@@ -2101,7 +2101,7 @@
           <a:lstStyle/>
           <a:p>
             <a:r>
-              <a:t>EN VIVO, breve: el lanzamiento del proyecto ABP tiene su propio deck; aquí solo la mención y el puente al H1. El proyecto se hace por parejas sobre un problema libre y debe cumplir ocho mínimos; ninguno es una funcionalidad: todos son decisiones de arquitectura verificables (el mínimo 2 incluye la regla de dependencias). El H1 (Actividad de aprendizaje 1, 20 %) vence el domingo 18 de octubre a las 11:59 p. m.: secciones 00 Gobierno y 01 Arquitectura del marco, más backlog priorizado y prototipo; la guía completa está en la Guía del proyecto ABP de la OVA. El H4 se socializa el viernes 6 de noviembre. Calendario: la Unidad 1 va del 5 al 11 de octubre; Encuentro 1 el viernes 9 de octubre de 6:00 a 7:00 p. m. por meet.google.com/pzh-kxer-pnx; la práctica opcional se trabaja del 9 al 11 de octubre; el Encuentro 2 (viernes 16 de octubre) incluye la clínica del H1.</a:t>
+              <a:t>EN VIVO, breve: el lanzamiento del proyecto de aula tiene su propio deck; aquí solo la mención y el puente al H1. El proyecto se hace por parejas sobre un problema libre y debe cumplir ocho mínimos; ninguno es una funcionalidad: todos son decisiones de arquitectura verificables (el mínimo 2 incluye la regla de dependencias). El H1 (Actividad de aprendizaje 1, 20 %) vence el domingo 18 de octubre a las 11:59 p. m.: secciones 00 Gobierno y 01 Arquitectura del marco, más backlog priorizado y prototipo; la guía completa está en la Guía del proyecto de aula de la OVA. El H4 es la entrega final del proyecto de aula: cada pareja diligencia el Informe del proyecto de aula (FO-IV-159), el formato institucional «Informe de proyectos de aula», y adjunta un .zip de anexos con fotos o capturas, el documento técnico del marco 00–05 en PDF, el repositorio, el AAB/APK firmado y el video; vence el domingo 8 de noviembre y se socializa el viernes 6 de noviembre. La metodología de trabajo la elige cada pareja. Calendario: la Unidad 1 va del 5 al 11 de octubre; Encuentro 1 el viernes 9 de octubre de 6:00 a 7:00 p. m. por meet.google.com/pzh-kxer-pnx; la práctica opcional se trabaja del 9 al 11 de octubre; el Encuentro 2 (viernes 16 de octubre) incluye la clínica del H1.</a:t>
             </a:r>
           </a:p>
         </p:txBody>
@@ -3221,7 +3221,7 @@
           <a:lstStyle/>
           <a:p>
             <a:r>
-              <a:t>EN VIVO: es el puente al H1. Detalle de la tabla: la descripción del proyecto va en docs/README.md y 00-gobierno/README.md; la estructura base, en estructura-del-proyecto.md y navegacion.md; el prototipo de interfaces son las fichas de pantallas/ y el backlog de al menos 10 historias priorizadas con MoSCoW va en 00-gobierno/backlog.md; el entorno de desarrollo y las pruebas iniciales, en el README.md raíz y la definición de hecho. Las plantillas en español están en las Plantillas del proyecto y el detalle del hito en la Guía del proyecto ABP, ambas en la OVA. El H1 vence el domingo 18 de octubre a las 11:59 p. m.</a:t>
+              <a:t>EN VIVO: es el puente al H1. Detalle de la tabla: la descripción del proyecto va en docs/README.md y 00-gobierno/README.md; la estructura base, en estructura-del-proyecto.md y navegacion.md; el prototipo de interfaces son las fichas de pantallas/ y el backlog de al menos 10 historias priorizadas con MoSCoW va en 00-gobierno/backlog.md; el entorno de desarrollo y las pruebas iniciales, en el README.md raíz y la definición de hecho. Las plantillas en español están en las Plantillas del proyecto y el detalle del hito en la Guía del proyecto de aula, ambas en la OVA. El H1 vence el domingo 18 de octubre a las 11:59 p. m.</a:t>
             </a:r>
           </a:p>
         </p:txBody>
@@ -36152,7 +36152,7 @@
                 </a:solidFill>
                 <a:latin typeface="Aptos Display"/>
               </a:rPr>
-              <a:t>El ABP: ocho mínimos, cuatro hitos</a:t>
+              <a:t>Proyecto de aula: 8 mínimos, 4 hitos</a:t>
             </a:r>
           </a:p>
         </p:txBody>
@@ -36878,7 +36878,7 @@
                           </a:solidFill>
                           <a:latin typeface="Aptos"/>
                         </a:rPr>
-                        <a:t>H4 · Documento ABP</a:t>
+                        <a:t>H4 · Informe FO-IV-159</a:t>
                       </a:r>
                     </a:p>
                   </a:txBody>
@@ -36944,7 +36944,7 @@
                           </a:solidFill>
                           <a:latin typeface="Aptos"/>
                         </a:rPr>
-                        <a:t>Marco 00–05 completo + evidencia</a:t>
+                        <a:t>Informe del proyecto de aula + .zip de anexos</a:t>
                       </a:r>
                     </a:p>
                   </a:txBody>
@@ -49176,7 +49176,7 @@
                           </a:solidFill>
                           <a:latin typeface="Aptos"/>
                         </a:rPr>
-                        <a:t>1.1 · Proyecto ABP</a:t>
+                        <a:t>1.1 · Proyecto de aula</a:t>
                       </a:r>
                     </a:p>
                   </a:txBody>

</xml_diff>